<commit_message>
Databasemanagement fase 2: interactieve leesversie + NoSQL-elective + Toolbijlage B
Interactieve leesversie (reader/werkboek/docentenhandleiding/slidedeck als
HTML, tabs + prev/next-navigatie + downloadkader) voor alle 30 delen, met
26 nieuw getekende figuren in Ductus-huisstijl (SVG, gerasterized naar PNG)
ingebed in zowel de HTML als de bijbehorende .docx/.pptx-downloads.

NoSQL-elective (2 delen, buiten de dertig-delen-nummering, geen aparte
certificeringslijn): werkt de vier scenario's uit deel 21 daadwerkelijk uit
in Redis, MongoDB, Cassandra en Neo4j.

Toolbijlage B: klikpaden voor pgAdmin en psql (kernhandelingen), als
vervolg op Toolbijlage A.

courses.json: downloadblok-notitie verwijderd nu de interactieve versie
live is. Build-tooling in databasemanagement-build/ (analoog aan
risico-build), bronscripts (figuur-generator, docx/pptx-converters) in
c:\Projecten\eductus-trainingen\Databasemanagement\scripts.
</commit_message>
<xml_diff>
--- a/databasemanagement/niveau-1/deel-01-databases-en-het-dbms-landschap-waarom-postgresql/slidedeck.pptx
+++ b/databasemanagement/niveau-1/deel-01-databases-en-het-dbms-landschap-waarom-postgresql/slidedeck.pptx
@@ -5730,70 +5730,29 @@
           <a:chExt cx="0" cy="0"/>
         </a:xfrm>
       </p:grpSpPr>
-      <p:sp>
-        <p:nvSpPr>
-          <p:cNvPr id="2" name="Shape 0"/>
-          <p:cNvSpPr/>
+      <p:pic>
+        <p:nvPicPr>
+          <p:cNvPr id="2" name="Image 0" descr="C:\Projecten\eductus-trainingen\Databasemanagement\databasecursus-output\_figures\figuur-1-3.png">    </p:cNvPr>
+          <p:cNvPicPr>
+            <a:picLocks noChangeAspect="1"/>
+          </p:cNvPicPr>
           <p:nvPr/>
-        </p:nvSpPr>
+        </p:nvPicPr>
+        <p:blipFill>
+          <a:blip r:embed="rId1"/>
+          <a:srcRect l="0" r="0" t="0" b="0"/>
+          <a:stretch/>
+        </p:blipFill>
         <p:spPr>
           <a:xfrm>
-            <a:off x="1371600" y="1280160"/>
-            <a:ext cx="9418320" cy="4389120"/>
+            <a:off x="1097280" y="1097280"/>
+            <a:ext cx="9966960" cy="4937760"/>
           </a:xfrm>
           <a:prstGeom prst="rect">
             <a:avLst/>
           </a:prstGeom>
-          <a:solidFill>
-            <a:srgbClr val="F4F2EC"/>
-          </a:solidFill>
-          <a:ln w="12700">
-            <a:solidFill>
-              <a:srgbClr val="DFDCD3"/>
-            </a:solidFill>
-            <a:prstDash val="dash"/>
-          </a:ln>
         </p:spPr>
-      </p:sp>
-      <p:sp>
-        <p:nvSpPr>
-          <p:cNvPr id="3" name="Text 1"/>
-          <p:cNvSpPr/>
-          <p:nvPr/>
-        </p:nvSpPr>
-        <p:spPr>
-          <a:xfrm>
-            <a:off x="1371600" y="1280160"/>
-            <a:ext cx="9418320" cy="4389120"/>
-          </a:xfrm>
-          <a:prstGeom prst="rect">
-            <a:avLst/>
-          </a:prstGeom>
-          <a:noFill/>
-          <a:ln/>
-        </p:spPr>
-        <p:txBody>
-          <a:bodyPr wrap="square" rtlCol="0" anchor="ctr"/>
-          <a:lstStyle/>
-          <a:p>
-            <a:pPr algn="ctr" indent="0" marL="0">
-              <a:buNone/>
-            </a:pPr>
-            <a:r>
-              <a:rPr lang="en-US" sz="1600" i="1" dirty="0">
-                <a:solidFill>
-                  <a:srgbClr val="55606F"/>
-                </a:solidFill>
-                <a:latin typeface="DM Sans" pitchFamily="34" charset="0"/>
-                <a:ea typeface="DM Sans" pitchFamily="34" charset="-122"/>
-                <a:cs typeface="DM Sans" pitchFamily="34" charset="-120"/>
-              </a:rPr>
-              <a:t>Figuur 1-3 — wordt toegevoegd bij de interactieve versie</a:t>
-            </a:r>
-            <a:endParaRPr lang="en-US" sz="1600" dirty="0"/>
-          </a:p>
-        </p:txBody>
-      </p:sp>
+      </p:pic>
     </p:spTree>
   </p:cSld>
   <p:clrMapOvr>
@@ -10024,73 +9983,32 @@
           <a:chExt cx="0" cy="0"/>
         </a:xfrm>
       </p:grpSpPr>
-      <p:sp>
-        <p:nvSpPr>
-          <p:cNvPr id="2" name="Shape 0"/>
-          <p:cNvSpPr/>
+      <p:pic>
+        <p:nvPicPr>
+          <p:cNvPr id="2" name="Image 0" descr="C:\Projecten\eductus-trainingen\Databasemanagement\databasecursus-output\_figures\figuur-1-4.png">    </p:cNvPr>
+          <p:cNvPicPr>
+            <a:picLocks noChangeAspect="1"/>
+          </p:cNvPicPr>
           <p:nvPr/>
-        </p:nvSpPr>
+        </p:nvPicPr>
+        <p:blipFill>
+          <a:blip r:embed="rId1"/>
+          <a:srcRect l="0" r="0" t="0" b="0"/>
+          <a:stretch/>
+        </p:blipFill>
         <p:spPr>
           <a:xfrm>
-            <a:off x="1371600" y="1280160"/>
-            <a:ext cx="9418320" cy="4389120"/>
+            <a:off x="1097280" y="1097280"/>
+            <a:ext cx="9966960" cy="4937760"/>
           </a:xfrm>
           <a:prstGeom prst="rect">
             <a:avLst/>
           </a:prstGeom>
-          <a:solidFill>
-            <a:srgbClr val="F4F2EC"/>
-          </a:solidFill>
-          <a:ln w="12700">
-            <a:solidFill>
-              <a:srgbClr val="DFDCD3"/>
-            </a:solidFill>
-            <a:prstDash val="dash"/>
-          </a:ln>
         </p:spPr>
-      </p:sp>
-      <p:sp>
-        <p:nvSpPr>
-          <p:cNvPr id="3" name="Text 1"/>
-          <p:cNvSpPr/>
-          <p:nvPr/>
-        </p:nvSpPr>
-        <p:spPr>
-          <a:xfrm>
-            <a:off x="1371600" y="1280160"/>
-            <a:ext cx="9418320" cy="4389120"/>
-          </a:xfrm>
-          <a:prstGeom prst="rect">
-            <a:avLst/>
-          </a:prstGeom>
-          <a:noFill/>
-          <a:ln/>
-        </p:spPr>
-        <p:txBody>
-          <a:bodyPr wrap="square" rtlCol="0" anchor="ctr"/>
-          <a:lstStyle/>
-          <a:p>
-            <a:pPr algn="ctr" indent="0" marL="0">
-              <a:buNone/>
-            </a:pPr>
-            <a:r>
-              <a:rPr lang="en-US" sz="1600" i="1" dirty="0">
-                <a:solidFill>
-                  <a:srgbClr val="55606F"/>
-                </a:solidFill>
-                <a:latin typeface="DM Sans" pitchFamily="34" charset="0"/>
-                <a:ea typeface="DM Sans" pitchFamily="34" charset="-122"/>
-                <a:cs typeface="DM Sans" pitchFamily="34" charset="-120"/>
-              </a:rPr>
-              <a:t>Figuur 1-4 — wordt toegevoegd bij de interactieve versie</a:t>
-            </a:r>
-            <a:endParaRPr lang="en-US" sz="1600" dirty="0"/>
-          </a:p>
-        </p:txBody>
-      </p:sp>
-      <p:sp>
-        <p:nvSpPr>
-          <p:cNvPr id="4" name="Text 2"/>
+      </p:pic>
+      <p:sp>
+        <p:nvSpPr>
+          <p:cNvPr id="3" name="Text 0"/>
           <p:cNvSpPr/>
           <p:nvPr/>
         </p:nvSpPr>
@@ -10827,73 +10745,32 @@
           </a:p>
         </p:txBody>
       </p:sp>
-      <p:sp>
-        <p:nvSpPr>
-          <p:cNvPr id="3" name="Shape 1"/>
-          <p:cNvSpPr/>
+      <p:pic>
+        <p:nvPicPr>
+          <p:cNvPr id="3" name="Image 0" descr="C:\Projecten\eductus-trainingen\Databasemanagement\databasecursus-output\_figures\figuur-1-1.png">    </p:cNvPr>
+          <p:cNvPicPr>
+            <a:picLocks noChangeAspect="1"/>
+          </p:cNvPicPr>
           <p:nvPr/>
-        </p:nvSpPr>
+        </p:nvPicPr>
+        <p:blipFill>
+          <a:blip r:embed="rId1"/>
+          <a:srcRect l="0" r="0" t="0" b="0"/>
+          <a:stretch/>
+        </p:blipFill>
         <p:spPr>
           <a:xfrm>
-            <a:off x="1371600" y="1280160"/>
-            <a:ext cx="9418320" cy="4389120"/>
+            <a:off x="1097280" y="1097280"/>
+            <a:ext cx="9966960" cy="4937760"/>
           </a:xfrm>
           <a:prstGeom prst="rect">
             <a:avLst/>
           </a:prstGeom>
-          <a:solidFill>
-            <a:srgbClr val="F4F2EC"/>
-          </a:solidFill>
-          <a:ln w="12700">
-            <a:solidFill>
-              <a:srgbClr val="DFDCD3"/>
-            </a:solidFill>
-            <a:prstDash val="dash"/>
-          </a:ln>
         </p:spPr>
-      </p:sp>
-      <p:sp>
-        <p:nvSpPr>
-          <p:cNvPr id="4" name="Text 2"/>
-          <p:cNvSpPr/>
-          <p:nvPr/>
-        </p:nvSpPr>
-        <p:spPr>
-          <a:xfrm>
-            <a:off x="1371600" y="1280160"/>
-            <a:ext cx="9418320" cy="4389120"/>
-          </a:xfrm>
-          <a:prstGeom prst="rect">
-            <a:avLst/>
-          </a:prstGeom>
-          <a:noFill/>
-          <a:ln/>
-        </p:spPr>
-        <p:txBody>
-          <a:bodyPr wrap="square" rtlCol="0" anchor="ctr"/>
-          <a:lstStyle/>
-          <a:p>
-            <a:pPr algn="ctr" indent="0" marL="0">
-              <a:buNone/>
-            </a:pPr>
-            <a:r>
-              <a:rPr lang="en-US" sz="1600" i="1" dirty="0">
-                <a:solidFill>
-                  <a:srgbClr val="55606F"/>
-                </a:solidFill>
-                <a:latin typeface="DM Sans" pitchFamily="34" charset="0"/>
-                <a:ea typeface="DM Sans" pitchFamily="34" charset="-122"/>
-                <a:cs typeface="DM Sans" pitchFamily="34" charset="-120"/>
-              </a:rPr>
-              <a:t>Figuur 1-1 — wordt toegevoegd bij de interactieve versie</a:t>
-            </a:r>
-            <a:endParaRPr lang="en-US" sz="1600" dirty="0"/>
-          </a:p>
-        </p:txBody>
-      </p:sp>
-      <p:sp>
-        <p:nvSpPr>
-          <p:cNvPr id="5" name="Text 3"/>
+      </p:pic>
+      <p:sp>
+        <p:nvSpPr>
+          <p:cNvPr id="4" name="Text 1"/>
           <p:cNvSpPr/>
           <p:nvPr/>
         </p:nvSpPr>

</xml_diff>